<commit_message>
feat: add team roster and Team ID BH26PS06T002 to Slide 1 across HTML, PPTX, and PDF
</commit_message>
<xml_diff>
--- a/SafeVision_AI_Presentation.pptx
+++ b/SafeVision_AI_Presentation.pptx
@@ -3220,8 +3220,8 @@
         </p:nvSpPr>
         <p:spPr>
           <a:xfrm>
-            <a:off x="731520" y="1508760"/>
-            <a:ext cx="10728655" cy="457200"/>
+            <a:off x="731520" y="1444752"/>
+            <a:ext cx="10728655" cy="594360"/>
           </a:xfrm>
           <a:prstGeom prst="rect">
             <a:avLst/>
@@ -3235,15 +3235,28 @@
           <a:lstStyle/>
           <a:p>
             <a:pPr>
-              <a:defRPr sz="1300">
-                <a:solidFill>
-                  <a:srgbClr val="94A3B8"/>
-                </a:solidFill>
-                <a:latin typeface="Arial"/>
-              </a:defRPr>
-            </a:pPr>
-            <a:r>
-              <a:t>STPI &amp; EmTek BPUT Hackathon Flagship Project • Edge AI Safety Platform</a:t>
+              <a:defRPr sz="1300" b="1">
+                <a:solidFill>
+                  <a:srgbClr val="38BDF8"/>
+                </a:solidFill>
+                <a:latin typeface="Arial"/>
+              </a:defRPr>
+            </a:pPr>
+            <a:r>
+              <a:t>STPI &amp; EmTek BPUT Hackathon Flagship Project  |  TEAM ID: BH26PS06T002</a:t>
+            </a:r>
+          </a:p>
+          <a:p>
+            <a:pPr>
+              <a:defRPr sz="1200" b="0">
+                <a:solidFill>
+                  <a:srgbClr val="CBD5E1"/>
+                </a:solidFill>
+                <a:latin typeface="Arial"/>
+              </a:defRPr>
+            </a:pPr>
+            <a:r>
+              <a:t>👥 Team Members: Subhakanta Muduli (Lead), Pradeep Kumar Sethi, Laxmipriya Jena, Biswaprakash Majhi</a:t>
             </a:r>
           </a:p>
         </p:txBody>
@@ -3451,7 +3464,7 @@
               </a:defRPr>
             </a:pPr>
             <a:r>
-              <a:t>SafeVision AI • STPI &amp; EmTek BPUT Hackathon Flagship Project • Live Demo Ready</a:t>
+              <a:t>SafeVision AI • STPI &amp; EmTek BPUT Hackathon Flagship Project • TEAM ID: BH26PS06T002 • Live Demo Ready</a:t>
             </a:r>
           </a:p>
         </p:txBody>

</xml_diff>